<commit_message>
Adjust math deck storyboard layout and update presentation outline
</commit_message>
<xml_diff>
--- a/presentation/Luna_Parafoil_NMPC_Math.pptx
+++ b/presentation/Luna_Parafoil_NMPC_Math.pptx
@@ -11679,8 +11679,8 @@
         </p:blipFill>
         <p:spPr>
           <a:xfrm>
-            <a:off x="502920" y="1234440"/>
-            <a:ext cx="5394960" cy="3034665"/>
+            <a:off x="502920" y="1051560"/>
+            <a:ext cx="3982720" cy="2240280"/>
           </a:xfrm>
           <a:prstGeom prst="rect">
             <a:avLst/>
@@ -11695,8 +11695,8 @@
         </p:nvSpPr>
         <p:spPr>
           <a:xfrm>
-            <a:off x="502920" y="3383280"/>
-            <a:ext cx="5394960" cy="256032"/>
+            <a:off x="502920" y="3310128"/>
+            <a:ext cx="5349240" cy="256032"/>
           </a:xfrm>
           <a:prstGeom prst="rect">
             <a:avLst/>
@@ -11721,13 +11721,13 @@
               </a:spcAft>
             </a:pPr>
             <a:r>
-              <a:rPr sz="1100" b="1" i="0">
+              <a:rPr sz="1200" b="1" i="0">
                 <a:solidFill>
                   <a:srgbClr val="35C8D6"/>
                 </a:solidFill>
                 <a:latin typeface="Calibri"/>
               </a:rPr>
-              <a:t>t ≈ 0 s  ·  release</a:t>
+              <a:t>t ≈ 0 s · release</a:t>
             </a:r>
           </a:p>
         </p:txBody>
@@ -11748,8 +11748,8 @@
         </p:blipFill>
         <p:spPr>
           <a:xfrm>
-            <a:off x="6309360" y="1234440"/>
-            <a:ext cx="5394960" cy="3034665"/>
+            <a:off x="6217920" y="1051560"/>
+            <a:ext cx="3982720" cy="2240280"/>
           </a:xfrm>
           <a:prstGeom prst="rect">
             <a:avLst/>
@@ -11764,8 +11764,8 @@
         </p:nvSpPr>
         <p:spPr>
           <a:xfrm>
-            <a:off x="6309360" y="3383280"/>
-            <a:ext cx="5394960" cy="256032"/>
+            <a:off x="6217920" y="3310128"/>
+            <a:ext cx="5349240" cy="256032"/>
           </a:xfrm>
           <a:prstGeom prst="rect">
             <a:avLst/>
@@ -11790,13 +11790,13 @@
               </a:spcAft>
             </a:pPr>
             <a:r>
-              <a:rPr sz="1100" b="1" i="0">
+              <a:rPr sz="1200" b="1" i="0">
                 <a:solidFill>
                   <a:srgbClr val="35C8D6"/>
                 </a:solidFill>
                 <a:latin typeface="Calibri"/>
               </a:rPr>
-              <a:t>t ≈ 15 s  ·  homing</a:t>
+              <a:t>t ≈ 15 s · homing</a:t>
             </a:r>
           </a:p>
         </p:txBody>
@@ -11817,8 +11817,8 @@
         </p:blipFill>
         <p:spPr>
           <a:xfrm>
-            <a:off x="502920" y="3794760"/>
-            <a:ext cx="5394960" cy="3034665"/>
+            <a:off x="502920" y="3675888"/>
+            <a:ext cx="3982720" cy="2240280"/>
           </a:xfrm>
           <a:prstGeom prst="rect">
             <a:avLst/>
@@ -11833,8 +11833,8 @@
         </p:nvSpPr>
         <p:spPr>
           <a:xfrm>
-            <a:off x="502920" y="5943600"/>
-            <a:ext cx="5394960" cy="256032"/>
+            <a:off x="502920" y="5934456"/>
+            <a:ext cx="5349240" cy="256032"/>
           </a:xfrm>
           <a:prstGeom prst="rect">
             <a:avLst/>
@@ -11859,20 +11859,20 @@
               </a:spcAft>
             </a:pPr>
             <a:r>
-              <a:rPr sz="1100" b="1" i="0">
+              <a:rPr sz="1200" b="1" i="0">
                 <a:solidFill>
                   <a:srgbClr val="35C8D6"/>
                 </a:solidFill>
                 <a:latin typeface="Calibri"/>
               </a:rPr>
-              <a:t>t ≈ 40 s  ·  mid-course</a:t>
+              <a:t>t ≈ 40 s · mid / loiter</a:t>
             </a:r>
           </a:p>
         </p:txBody>
       </p:sp>
       <p:pic>
         <p:nvPicPr>
-          <p:cNvPr id="11" name="Picture 10" descr="t55_approach.png"/>
+          <p:cNvPr id="11" name="Picture 10" descr="t_end_touchdown.png"/>
           <p:cNvPicPr>
             <a:picLocks noChangeAspect="1"/>
           </p:cNvPicPr>
@@ -11886,8 +11886,8 @@
         </p:blipFill>
         <p:spPr>
           <a:xfrm>
-            <a:off x="6309360" y="3794760"/>
-            <a:ext cx="5394960" cy="3034665"/>
+            <a:off x="6217920" y="3675888"/>
+            <a:ext cx="3982720" cy="2240280"/>
           </a:xfrm>
           <a:prstGeom prst="rect">
             <a:avLst/>
@@ -11902,8 +11902,8 @@
         </p:nvSpPr>
         <p:spPr>
           <a:xfrm>
-            <a:off x="6309360" y="5943600"/>
-            <a:ext cx="5394960" cy="256032"/>
+            <a:off x="6217920" y="5934456"/>
+            <a:ext cx="5349240" cy="256032"/>
           </a:xfrm>
           <a:prstGeom prst="rect">
             <a:avLst/>
@@ -11928,13 +11928,13 @@
               </a:spcAft>
             </a:pPr>
             <a:r>
-              <a:rPr sz="1100" b="1" i="0">
+              <a:rPr sz="1200" b="1" i="0">
                 <a:solidFill>
                   <a:srgbClr val="35C8D6"/>
                 </a:solidFill>
                 <a:latin typeface="Calibri"/>
               </a:rPr>
-              <a:t>t ≈ 55 s  ·  approach</a:t>
+              <a:t>touchdown</a:t>
             </a:r>
           </a:p>
         </p:txBody>

</xml_diff>